<commit_message>
docs(presentation): title slide reads CPI PROJECT EVALUATION
</commit_message>
<xml_diff>
--- a/presentation/CivicPulse-pitch.pptx
+++ b/presentation/CivicPulse-pitch.pptx
@@ -138,18 +138,18 @@
   <p:extLst>
     <p:ext uri="{521415D9-36F7-43E2-AB2F-B90AF26B5E84}">
       <p14:sectionLst xmlns:p14="http://schemas.microsoft.com/office/powerpoint/2010/main">
-        <p14:section name="Opening" id="{805F6216-6876-DD23-580F-B6711C584653}">
+        <p14:section name="Opening" id="{38B0ED81-42A8-7771-EBC2-0CD134E31414}">
           <p14:sldIdLst>
             <p14:sldId id="256"/>
           </p14:sldIdLst>
         </p14:section>
-        <p14:section name="Problem and solution" id="{94FE1E35-6B23-BC1C-48FF-1167EC1979CA}">
+        <p14:section name="Problem and solution" id="{E6D514CC-8722-1A86-1A4A-C29310A61FF9}">
           <p14:sldIdLst>
             <p14:sldId id="257"/>
             <p14:sldId id="258"/>
           </p14:sldIdLst>
         </p14:section>
-        <p14:section name="How it works" id="{621442BE-1276-5524-219D-4731CBF6905D}">
+        <p14:section name="How it works" id="{1CD9519A-5D55-13EC-595E-6AF6BCE09DE8}">
           <p14:sldIdLst>
             <p14:sldId id="259"/>
             <p14:sldId id="260"/>
@@ -157,7 +157,7 @@
             <p14:sldId id="262"/>
           </p14:sldIdLst>
         </p14:section>
-        <p14:section name="Results and next steps" id="{6BF9F702-E63C-904F-FCFC-BB7CCFFCA9D0}">
+        <p14:section name="Results and next steps" id="{A5460B53-CBDB-1591-D9C9-4DF98A3A1274}">
           <p14:sldIdLst>
             <p14:sldId id="263"/>
             <p14:sldId id="264"/>
@@ -323,7 +323,7 @@
           <c:smooth val="0"/>
           <c:extLst>
             <c:ext xmlns:c16="http://schemas.microsoft.com/office/drawing/2014/chart" uri="{C3380CC4-5D6E-409C-BE32-E72D297353CC}">
-              <c16:uniqueId val="{00000000-B00B-40CB-941E-F7F654E445D9}"/>
+              <c16:uniqueId val="{00000000-E79F-48EF-B884-7B8454A5A9C4}"/>
             </c:ext>
           </c:extLst>
         </c:ser>
@@ -436,7 +436,7 @@
           <c:smooth val="0"/>
           <c:extLst>
             <c:ext xmlns:c16="http://schemas.microsoft.com/office/drawing/2014/chart" uri="{C3380CC4-5D6E-409C-BE32-E72D297353CC}">
-              <c16:uniqueId val="{00000001-B00B-40CB-941E-F7F654E445D9}"/>
+              <c16:uniqueId val="{00000001-E79F-48EF-B884-7B8454A5A9C4}"/>
             </c:ext>
           </c:extLst>
         </c:ser>
@@ -728,7 +728,7 @@
           </c:val>
           <c:extLst>
             <c:ext xmlns:c16="http://schemas.microsoft.com/office/drawing/2014/chart" uri="{C3380CC4-5D6E-409C-BE32-E72D297353CC}">
-              <c16:uniqueId val="{00000000-7635-4FEC-A375-8F282B862220}"/>
+              <c16:uniqueId val="{00000000-68D7-4473-B34F-61C30E59691D}"/>
             </c:ext>
           </c:extLst>
         </c:ser>
@@ -827,7 +827,7 @@
           </c:val>
           <c:extLst>
             <c:ext xmlns:c16="http://schemas.microsoft.com/office/drawing/2014/chart" uri="{C3380CC4-5D6E-409C-BE32-E72D297353CC}">
-              <c16:uniqueId val="{00000001-7635-4FEC-A375-8F282B862220}"/>
+              <c16:uniqueId val="{00000001-68D7-4473-B34F-61C30E59691D}"/>
             </c:ext>
           </c:extLst>
         </c:ser>
@@ -926,7 +926,7 @@
           </c:val>
           <c:extLst>
             <c:ext xmlns:c16="http://schemas.microsoft.com/office/drawing/2014/chart" uri="{C3380CC4-5D6E-409C-BE32-E72D297353CC}">
-              <c16:uniqueId val="{00000002-7635-4FEC-A375-8F282B862220}"/>
+              <c16:uniqueId val="{00000002-68D7-4473-B34F-61C30E59691D}"/>
             </c:ext>
           </c:extLst>
         </c:ser>
@@ -1105,7 +1105,7 @@
     </p:spTree>
     <p:extLst>
       <p:ext uri="{BB962C8B-B14F-4D97-AF65-F5344CB8AC3E}">
-        <p14:creationId xmlns:p14="http://schemas.microsoft.com/office/powerpoint/2010/main" val="2616624289"/>
+        <p14:creationId xmlns:p14="http://schemas.microsoft.com/office/powerpoint/2010/main" val="3918955682"/>
       </p:ext>
     </p:extLst>
   </p:cSld>
@@ -2769,7 +2769,7 @@
                 <a:ea typeface="Poppins SemiBold" pitchFamily="34" charset="-122"/>
                 <a:cs typeface="Poppins SemiBold" pitchFamily="34" charset="-120"/>
               </a:rPr>
-              <a:t>TEAM PROJECT  ·  BENGALURU  ·  2026</a:t>
+              <a:t>CPI PROJECT EVALUATION</a:t>
             </a:r>
             <a:endParaRPr lang="en-US" sz="1200" dirty="0"/>
           </a:p>

</xml_diff>